<commit_message>
Updated code and model outputs
</commit_message>
<xml_diff>
--- a/Figures/mcp_model_testing.pptx
+++ b/Figures/mcp_model_testing.pptx
@@ -107,6 +107,11 @@
       </a:defRPr>
     </a:lvl9pPr>
   </p:defaultTextStyle>
+  <p:extLst>
+    <p:ext uri="{EFAFB233-063F-42B5-8137-9DF3F51BA10A}">
+      <p15:sldGuideLst xmlns:p15="http://schemas.microsoft.com/office/powerpoint/2012/main"/>
+    </p:ext>
+  </p:extLst>
 </p:presentation>
 </file>
 
@@ -241,7 +246,7 @@
           <a:p>
             <a:fld id="{4DE30440-D0B7-4413-8C4F-A5751CEF63CE}" type="datetimeFigureOut">
               <a:rPr lang="en-US" smtClean="0"/>
-              <a:t>1/15/2026</a:t>
+              <a:t>1/21/2026</a:t>
             </a:fld>
             <a:endParaRPr lang="en-US"/>
           </a:p>
@@ -411,7 +416,7 @@
           <a:p>
             <a:fld id="{4DE30440-D0B7-4413-8C4F-A5751CEF63CE}" type="datetimeFigureOut">
               <a:rPr lang="en-US" smtClean="0"/>
-              <a:t>1/15/2026</a:t>
+              <a:t>1/21/2026</a:t>
             </a:fld>
             <a:endParaRPr lang="en-US"/>
           </a:p>
@@ -591,7 +596,7 @@
           <a:p>
             <a:fld id="{4DE30440-D0B7-4413-8C4F-A5751CEF63CE}" type="datetimeFigureOut">
               <a:rPr lang="en-US" smtClean="0"/>
-              <a:t>1/15/2026</a:t>
+              <a:t>1/21/2026</a:t>
             </a:fld>
             <a:endParaRPr lang="en-US"/>
           </a:p>
@@ -761,7 +766,7 @@
           <a:p>
             <a:fld id="{4DE30440-D0B7-4413-8C4F-A5751CEF63CE}" type="datetimeFigureOut">
               <a:rPr lang="en-US" smtClean="0"/>
-              <a:t>1/15/2026</a:t>
+              <a:t>1/21/2026</a:t>
             </a:fld>
             <a:endParaRPr lang="en-US"/>
           </a:p>
@@ -1007,7 +1012,7 @@
           <a:p>
             <a:fld id="{4DE30440-D0B7-4413-8C4F-A5751CEF63CE}" type="datetimeFigureOut">
               <a:rPr lang="en-US" smtClean="0"/>
-              <a:t>1/15/2026</a:t>
+              <a:t>1/21/2026</a:t>
             </a:fld>
             <a:endParaRPr lang="en-US"/>
           </a:p>
@@ -1239,7 +1244,7 @@
           <a:p>
             <a:fld id="{4DE30440-D0B7-4413-8C4F-A5751CEF63CE}" type="datetimeFigureOut">
               <a:rPr lang="en-US" smtClean="0"/>
-              <a:t>1/15/2026</a:t>
+              <a:t>1/21/2026</a:t>
             </a:fld>
             <a:endParaRPr lang="en-US"/>
           </a:p>
@@ -1606,7 +1611,7 @@
           <a:p>
             <a:fld id="{4DE30440-D0B7-4413-8C4F-A5751CEF63CE}" type="datetimeFigureOut">
               <a:rPr lang="en-US" smtClean="0"/>
-              <a:t>1/15/2026</a:t>
+              <a:t>1/21/2026</a:t>
             </a:fld>
             <a:endParaRPr lang="en-US"/>
           </a:p>
@@ -1724,7 +1729,7 @@
           <a:p>
             <a:fld id="{4DE30440-D0B7-4413-8C4F-A5751CEF63CE}" type="datetimeFigureOut">
               <a:rPr lang="en-US" smtClean="0"/>
-              <a:t>1/15/2026</a:t>
+              <a:t>1/21/2026</a:t>
             </a:fld>
             <a:endParaRPr lang="en-US"/>
           </a:p>
@@ -1819,7 +1824,7 @@
           <a:p>
             <a:fld id="{4DE30440-D0B7-4413-8C4F-A5751CEF63CE}" type="datetimeFigureOut">
               <a:rPr lang="en-US" smtClean="0"/>
-              <a:t>1/15/2026</a:t>
+              <a:t>1/21/2026</a:t>
             </a:fld>
             <a:endParaRPr lang="en-US"/>
           </a:p>
@@ -2096,7 +2101,7 @@
           <a:p>
             <a:fld id="{4DE30440-D0B7-4413-8C4F-A5751CEF63CE}" type="datetimeFigureOut">
               <a:rPr lang="en-US" smtClean="0"/>
-              <a:t>1/15/2026</a:t>
+              <a:t>1/21/2026</a:t>
             </a:fld>
             <a:endParaRPr lang="en-US"/>
           </a:p>
@@ -2353,7 +2358,7 @@
           <a:p>
             <a:fld id="{4DE30440-D0B7-4413-8C4F-A5751CEF63CE}" type="datetimeFigureOut">
               <a:rPr lang="en-US" smtClean="0"/>
-              <a:t>1/15/2026</a:t>
+              <a:t>1/21/2026</a:t>
             </a:fld>
             <a:endParaRPr lang="en-US"/>
           </a:p>
@@ -2566,7 +2571,7 @@
           <a:p>
             <a:fld id="{4DE30440-D0B7-4413-8C4F-A5751CEF63CE}" type="datetimeFigureOut">
               <a:rPr lang="en-US" smtClean="0"/>
-              <a:t>1/15/2026</a:t>
+              <a:t>1/21/2026</a:t>
             </a:fld>
             <a:endParaRPr lang="en-US"/>
           </a:p>
@@ -2973,7 +2978,7 @@
       </p:grpSpPr>
       <p:pic>
         <p:nvPicPr>
-          <p:cNvPr id="9" name="Picture 8" descr="A graph of a test results&#10;&#10;AI-generated content may be incorrect.">
+          <p:cNvPr id="9" name="Picture 8">
             <a:extLst>
               <a:ext uri="{FF2B5EF4-FFF2-40B4-BE49-F238E27FC236}">
                 <a16:creationId xmlns:a16="http://schemas.microsoft.com/office/drawing/2014/main" id="{F8F33440-B9B6-6877-89DF-7B3D23B8BDEE}"/>
@@ -2993,9 +2998,8 @@
               </a:ext>
             </a:extLst>
           </a:blip>
-          <a:stretch>
-            <a:fillRect/>
-          </a:stretch>
+          <a:srcRect/>
+          <a:stretch/>
         </p:blipFill>
         <p:spPr>
           <a:xfrm>
@@ -3009,7 +3013,7 @@
       </p:pic>
       <p:pic>
         <p:nvPicPr>
-          <p:cNvPr id="5" name="Picture 4" descr="A comparison of a graph&#10;&#10;AI-generated content may be incorrect.">
+          <p:cNvPr id="5" name="Picture 4">
             <a:extLst>
               <a:ext uri="{FF2B5EF4-FFF2-40B4-BE49-F238E27FC236}">
                 <a16:creationId xmlns:a16="http://schemas.microsoft.com/office/drawing/2014/main" id="{8C4D7BB3-3D19-39B9-415B-00075D3D95AE}"/>
@@ -3029,10 +3033,8 @@
               </a:ext>
             </a:extLst>
           </a:blip>
-          <a:srcRect r="2070"/>
-          <a:stretch>
-            <a:fillRect/>
-          </a:stretch>
+          <a:srcRect l="1035" r="1035"/>
+          <a:stretch/>
         </p:blipFill>
         <p:spPr>
           <a:xfrm>
@@ -3199,7 +3201,7 @@
       </p:sp>
       <p:pic>
         <p:nvPicPr>
-          <p:cNvPr id="12" name="Picture 11" descr="A comparison of graphs and diagrams&#10;&#10;AI-generated content may be incorrect.">
+          <p:cNvPr id="12" name="Picture 11">
             <a:extLst>
               <a:ext uri="{FF2B5EF4-FFF2-40B4-BE49-F238E27FC236}">
                 <a16:creationId xmlns:a16="http://schemas.microsoft.com/office/drawing/2014/main" id="{8D3D8D13-0CE9-CCA9-5141-D384F252443C}"/>
@@ -3219,9 +3221,8 @@
               </a:ext>
             </a:extLst>
           </a:blip>
-          <a:stretch>
-            <a:fillRect/>
-          </a:stretch>
+          <a:srcRect/>
+          <a:stretch/>
         </p:blipFill>
         <p:spPr>
           <a:xfrm>
@@ -3286,7 +3287,7 @@
       </p:sp>
       <p:pic>
         <p:nvPicPr>
-          <p:cNvPr id="15" name="Picture 14" descr="A comparison of a graph&#10;&#10;AI-generated content may be incorrect.">
+          <p:cNvPr id="15" name="Picture 14">
             <a:extLst>
               <a:ext uri="{FF2B5EF4-FFF2-40B4-BE49-F238E27FC236}">
                 <a16:creationId xmlns:a16="http://schemas.microsoft.com/office/drawing/2014/main" id="{DABB8394-02BB-BAE5-4A8C-703688F51B21}"/>
@@ -3306,9 +3307,8 @@
               </a:ext>
             </a:extLst>
           </a:blip>
-          <a:stretch>
-            <a:fillRect/>
-          </a:stretch>
+          <a:srcRect/>
+          <a:stretch/>
         </p:blipFill>
         <p:spPr>
           <a:xfrm>
@@ -3352,7 +3352,7 @@
       </p:grpSpPr>
       <p:pic>
         <p:nvPicPr>
-          <p:cNvPr id="3" name="Picture 2" descr="A graph of numbers and a number of observation&#10;&#10;AI-generated content may be incorrect.">
+          <p:cNvPr id="3" name="Picture 2">
             <a:extLst>
               <a:ext uri="{FF2B5EF4-FFF2-40B4-BE49-F238E27FC236}">
                 <a16:creationId xmlns:a16="http://schemas.microsoft.com/office/drawing/2014/main" id="{0824DE39-F9D8-5957-33E1-2146FE942429}"/>
@@ -3372,9 +3372,8 @@
               </a:ext>
             </a:extLst>
           </a:blip>
-          <a:stretch>
-            <a:fillRect/>
-          </a:stretch>
+          <a:srcRect/>
+          <a:stretch/>
         </p:blipFill>
         <p:spPr>
           <a:xfrm>
@@ -3388,7 +3387,7 @@
       </p:pic>
       <p:pic>
         <p:nvPicPr>
-          <p:cNvPr id="5" name="Picture 4" descr="A graph of a number of numbers&#10;&#10;AI-generated content may be incorrect.">
+          <p:cNvPr id="5" name="Picture 4">
             <a:extLst>
               <a:ext uri="{FF2B5EF4-FFF2-40B4-BE49-F238E27FC236}">
                 <a16:creationId xmlns:a16="http://schemas.microsoft.com/office/drawing/2014/main" id="{68A58F74-479D-84F3-804C-40CF6A6907C3}"/>
@@ -3408,9 +3407,8 @@
               </a:ext>
             </a:extLst>
           </a:blip>
-          <a:stretch>
-            <a:fillRect/>
-          </a:stretch>
+          <a:srcRect/>
+          <a:stretch/>
         </p:blipFill>
         <p:spPr>
           <a:xfrm>
@@ -3524,7 +3522,7 @@
       </p:grpSpPr>
       <p:pic>
         <p:nvPicPr>
-          <p:cNvPr id="3" name="Picture 2" descr="A graph of a test&#10;&#10;AI-generated content may be incorrect.">
+          <p:cNvPr id="3" name="Picture 2">
             <a:extLst>
               <a:ext uri="{FF2B5EF4-FFF2-40B4-BE49-F238E27FC236}">
                 <a16:creationId xmlns:a16="http://schemas.microsoft.com/office/drawing/2014/main" id="{AB7D24CD-4A6F-6DC8-3DC2-84DE3B154666}"/>
@@ -3544,9 +3542,8 @@
               </a:ext>
             </a:extLst>
           </a:blip>
-          <a:stretch>
-            <a:fillRect/>
-          </a:stretch>
+          <a:srcRect/>
+          <a:stretch/>
         </p:blipFill>
         <p:spPr>
           <a:xfrm>
@@ -3796,7 +3793,7 @@
       </p:sp>
       <p:pic>
         <p:nvPicPr>
-          <p:cNvPr id="9" name="Picture 8" descr="A comparison of a graph&#10;&#10;AI-generated content may be incorrect.">
+          <p:cNvPr id="9" name="Picture 8">
             <a:extLst>
               <a:ext uri="{FF2B5EF4-FFF2-40B4-BE49-F238E27FC236}">
                 <a16:creationId xmlns:a16="http://schemas.microsoft.com/office/drawing/2014/main" id="{8D4E99DD-D151-9DCE-9A6D-D147C38D7922}"/>
@@ -3816,9 +3813,8 @@
               </a:ext>
             </a:extLst>
           </a:blip>
-          <a:stretch>
-            <a:fillRect/>
-          </a:stretch>
+          <a:srcRect/>
+          <a:stretch/>
         </p:blipFill>
         <p:spPr>
           <a:xfrm>
@@ -3832,7 +3828,7 @@
       </p:pic>
       <p:pic>
         <p:nvPicPr>
-          <p:cNvPr id="11" name="Picture 10" descr="A graph of a test&#10;&#10;AI-generated content may be incorrect.">
+          <p:cNvPr id="11" name="Picture 10">
             <a:extLst>
               <a:ext uri="{FF2B5EF4-FFF2-40B4-BE49-F238E27FC236}">
                 <a16:creationId xmlns:a16="http://schemas.microsoft.com/office/drawing/2014/main" id="{7F9F8644-B276-C8E1-AE6D-EB5590051897}"/>
@@ -3852,14 +3848,13 @@
               </a:ext>
             </a:extLst>
           </a:blip>
-          <a:stretch>
-            <a:fillRect/>
-          </a:stretch>
+          <a:srcRect/>
+          <a:stretch/>
         </p:blipFill>
         <p:spPr>
           <a:xfrm>
             <a:off x="19457" y="499583"/>
-            <a:ext cx="7393621" cy="5545216"/>
+            <a:ext cx="7393621" cy="5545215"/>
           </a:xfrm>
           <a:prstGeom prst="rect">
             <a:avLst/>
@@ -3868,7 +3863,7 @@
       </p:pic>
       <p:pic>
         <p:nvPicPr>
-          <p:cNvPr id="13" name="Picture 12" descr="A comparison of a graph&#10;&#10;AI-generated content may be incorrect.">
+          <p:cNvPr id="13" name="Picture 12">
             <a:extLst>
               <a:ext uri="{FF2B5EF4-FFF2-40B4-BE49-F238E27FC236}">
                 <a16:creationId xmlns:a16="http://schemas.microsoft.com/office/drawing/2014/main" id="{1470AF84-14A5-9D2A-0D26-2E20E8DB6A03}"/>
@@ -3888,14 +3883,13 @@
               </a:ext>
             </a:extLst>
           </a:blip>
-          <a:stretch>
-            <a:fillRect/>
-          </a:stretch>
+          <a:srcRect/>
+          <a:stretch/>
         </p:blipFill>
         <p:spPr>
           <a:xfrm>
             <a:off x="7236780" y="499583"/>
-            <a:ext cx="7393621" cy="5545216"/>
+            <a:ext cx="7393621" cy="5545215"/>
           </a:xfrm>
           <a:prstGeom prst="rect">
             <a:avLst/>

</xml_diff>